<commit_message>
Update sample: custom-drawn bar chart (replaces native PowerPoint chart)
Bar chart now uses rounded_rect shapes with gridlines and score labels,
matching the IM builder's approach. Better brand control on dark backgrounds.
</commit_message>
<xml_diff>
--- a/samples/Shruti_Revolut_WhyHireMe_Portfolio.pptx
+++ b/samples/Shruti_Revolut_WhyHireMe_Portfolio.pptx
@@ -116,269 +116,6 @@
 </file>
 
 <file path=ppt/charts/chart1.xml><?xml version="1.0" encoding="utf-8"?>
-<c:chartSpace xmlns:c="http://schemas.openxmlformats.org/drawingml/2006/chart" xmlns:a="http://schemas.openxmlformats.org/drawingml/2006/main" xmlns:r="http://schemas.openxmlformats.org/officeDocument/2006/relationships">
-  <c:date1904 val="0"/>
-  <c:chart>
-    <c:autoTitleDeleted val="0"/>
-    <c:plotArea>
-      <c:barChart>
-        <c:barDir val="bar"/>
-        <c:grouping val="clustered"/>
-        <c:ser>
-          <c:idx val="0"/>
-          <c:order val="0"/>
-          <c:tx>
-            <c:strRef>
-              <c:f>Sheet1!$B$1</c:f>
-              <c:strCache>
-                <c:ptCount val="1"/>
-                <c:pt idx="0">
-                  <c:v>JD Requirement</c:v>
-                </c:pt>
-              </c:strCache>
-            </c:strRef>
-          </c:tx>
-          <c:spPr>
-            <a:solidFill>
-              <a:srgbClr val="5A5A5E"/>
-            </a:solidFill>
-          </c:spPr>
-          <c:cat>
-            <c:strRef>
-              <c:f>Sheet1!$A$2:$A$7</c:f>
-              <c:strCache>
-                <c:ptCount val="6"/>
-                <c:pt idx="0">
-                  <c:v>Product strategy
-&amp; roadmaps</c:v>
-                </c:pt>
-                <c:pt idx="1">
-                  <c:v>Data analysis
-&amp; user insights</c:v>
-                </c:pt>
-                <c:pt idx="2">
-                  <c:v>Cross-functional
-collaboration</c:v>
-                </c:pt>
-                <c:pt idx="3">
-                  <c:v>User testing
-&amp; iteration</c:v>
-                </c:pt>
-                <c:pt idx="4">
-                  <c:v>Tracking &amp;
-communication</c:v>
-                </c:pt>
-                <c:pt idx="5">
-                  <c:v>Startup /
-entrepreneurial</c:v>
-                </c:pt>
-              </c:strCache>
-            </c:strRef>
-          </c:cat>
-          <c:val>
-            <c:numRef>
-              <c:f>Sheet1!$B$2:$B$7</c:f>
-              <c:numCache>
-                <c:formatCode>General</c:formatCode>
-                <c:ptCount val="6"/>
-                <c:pt idx="0">
-                  <c:v>10</c:v>
-                </c:pt>
-                <c:pt idx="1">
-                  <c:v>10</c:v>
-                </c:pt>
-                <c:pt idx="2">
-                  <c:v>10</c:v>
-                </c:pt>
-                <c:pt idx="3">
-                  <c:v>10</c:v>
-                </c:pt>
-                <c:pt idx="4">
-                  <c:v>10</c:v>
-                </c:pt>
-                <c:pt idx="5">
-                  <c:v>5</c:v>
-                </c:pt>
-              </c:numCache>
-            </c:numRef>
-          </c:val>
-        </c:ser>
-        <c:ser>
-          <c:idx val="1"/>
-          <c:order val="1"/>
-          <c:tx>
-            <c:strRef>
-              <c:f>Sheet1!$C$1</c:f>
-              <c:strCache>
-                <c:ptCount val="1"/>
-                <c:pt idx="0">
-                  <c:v>Shruti Evidence</c:v>
-                </c:pt>
-              </c:strCache>
-            </c:strRef>
-          </c:tx>
-          <c:spPr>
-            <a:solidFill>
-              <a:srgbClr val="0066FF"/>
-            </a:solidFill>
-          </c:spPr>
-          <c:cat>
-            <c:strRef>
-              <c:f>Sheet1!$A$2:$A$7</c:f>
-              <c:strCache>
-                <c:ptCount val="6"/>
-                <c:pt idx="0">
-                  <c:v>Product strategy
-&amp; roadmaps</c:v>
-                </c:pt>
-                <c:pt idx="1">
-                  <c:v>Data analysis
-&amp; user insights</c:v>
-                </c:pt>
-                <c:pt idx="2">
-                  <c:v>Cross-functional
-collaboration</c:v>
-                </c:pt>
-                <c:pt idx="3">
-                  <c:v>User testing
-&amp; iteration</c:v>
-                </c:pt>
-                <c:pt idx="4">
-                  <c:v>Tracking &amp;
-communication</c:v>
-                </c:pt>
-                <c:pt idx="5">
-                  <c:v>Startup /
-entrepreneurial</c:v>
-                </c:pt>
-              </c:strCache>
-            </c:strRef>
-          </c:cat>
-          <c:val>
-            <c:numRef>
-              <c:f>Sheet1!$C$2:$C$7</c:f>
-              <c:numCache>
-                <c:formatCode>General</c:formatCode>
-                <c:ptCount val="6"/>
-                <c:pt idx="0">
-                  <c:v>9</c:v>
-                </c:pt>
-                <c:pt idx="1">
-                  <c:v>9</c:v>
-                </c:pt>
-                <c:pt idx="2">
-                  <c:v>10</c:v>
-                </c:pt>
-                <c:pt idx="3">
-                  <c:v>8</c:v>
-                </c:pt>
-                <c:pt idx="4">
-                  <c:v>9</c:v>
-                </c:pt>
-                <c:pt idx="5">
-                  <c:v>10</c:v>
-                </c:pt>
-              </c:numCache>
-            </c:numRef>
-          </c:val>
-        </c:ser>
-        <c:axId val="-2068027336"/>
-        <c:axId val="-2113994440"/>
-      </c:barChart>
-      <c:catAx>
-        <c:axId val="-2068027336"/>
-        <c:scaling>
-          <c:orientation val="minMax"/>
-        </c:scaling>
-        <c:delete val="0"/>
-        <c:axPos val="l"/>
-        <c:majorTickMark val="out"/>
-        <c:minorTickMark val="none"/>
-        <c:tickLblPos val="nextTo"/>
-        <c:txPr>
-          <a:bodyPr/>
-          <a:lstStyle/>
-          <a:p>
-            <a:pPr>
-              <a:defRPr sz="800">
-                <a:solidFill>
-                  <a:srgbClr val="A0A0A0"/>
-                </a:solidFill>
-                <a:latin typeface="Inter"/>
-              </a:defRPr>
-            </a:pPr>
-          </a:p>
-        </c:txPr>
-        <c:crossAx val="-2113994440"/>
-        <c:crosses val="autoZero"/>
-        <c:auto val="1"/>
-        <c:lblAlgn val="ctr"/>
-        <c:lblOffset val="100"/>
-        <c:noMultiLvlLbl val="0"/>
-      </c:catAx>
-      <c:valAx>
-        <c:axId val="-2113994440"/>
-        <c:scaling/>
-        <c:delete val="0"/>
-        <c:axPos val="b"/>
-        <c:majorGridlines/>
-        <c:majorTickMark val="out"/>
-        <c:minorTickMark val="none"/>
-        <c:tickLblPos val="nextTo"/>
-        <c:txPr>
-          <a:bodyPr/>
-          <a:lstStyle/>
-          <a:p>
-            <a:pPr>
-              <a:defRPr sz="800">
-                <a:solidFill>
-                  <a:srgbClr val="A0A0A0"/>
-                </a:solidFill>
-                <a:latin typeface="Inter"/>
-              </a:defRPr>
-            </a:pPr>
-          </a:p>
-        </c:txPr>
-        <c:crossAx val="-2068027336"/>
-        <c:crosses val="autoZero"/>
-      </c:valAx>
-    </c:plotArea>
-    <c:legend>
-      <c:legendPos val="b"/>
-      <c:overlay val="0"/>
-      <c:txPr>
-        <a:bodyPr/>
-        <a:lstStyle/>
-        <a:p>
-          <a:pPr>
-            <a:defRPr sz="800">
-              <a:solidFill>
-                <a:srgbClr val="A0A0A0"/>
-              </a:solidFill>
-            </a:defRPr>
-          </a:pPr>
-        </a:p>
-      </c:txPr>
-    </c:legend>
-    <c:dispBlanksAs val="gap"/>
-  </c:chart>
-  <c:txPr>
-    <a:bodyPr/>
-    <a:lstStyle/>
-    <a:p>
-      <a:pPr>
-        <a:defRPr sz="1800"/>
-      </a:pPr>
-      <a:endParaRPr lang="en-US"/>
-    </a:p>
-  </c:txPr>
-  <c:externalData r:id="rId1">
-    <c:autoUpdate val="0"/>
-  </c:externalData>
-</c:chartSpace>
-</file>
-
-<file path=ppt/charts/chart2.xml><?xml version="1.0" encoding="utf-8"?>
 <c:chartSpace xmlns:c="http://schemas.openxmlformats.org/drawingml/2006/chart" xmlns:a="http://schemas.openxmlformats.org/drawingml/2006/main" xmlns:r="http://schemas.openxmlformats.org/officeDocument/2006/relationships">
   <c:date1904 val="0"/>
   <c:roundedCorners val="0"/>
@@ -4427,24 +4164,50 @@
           </a:p>
         </p:txBody>
       </p:sp>
-      <p:graphicFrame>
-        <p:nvGraphicFramePr>
-          <p:cNvPr id="4" name="Chart 3"/>
-          <p:cNvGraphicFramePr>
-            <a:graphicFrameLocks noGrp="1"/>
-          </p:cNvGraphicFramePr>
-          <p:nvPr/>
-        </p:nvGraphicFramePr>
-        <p:xfrm>
-          <a:off x="274320" y="914400"/>
-          <a:ext cx="5486400" cy="3840480"/>
-        </p:xfrm>
-        <a:graphic>
-          <a:graphicData uri="http://schemas.openxmlformats.org/drawingml/2006/chart">
-            <c:chart xmlns:c="http://schemas.openxmlformats.org/drawingml/2006/chart" r:id="rId3"/>
-          </a:graphicData>
-        </a:graphic>
-      </p:graphicFrame>
+      <p:sp>
+        <p:nvSpPr>
+          <p:cNvPr id="4" name="Rectangle 3"/>
+          <p:cNvSpPr/>
+          <p:nvPr/>
+        </p:nvSpPr>
+        <p:spPr>
+          <a:xfrm>
+            <a:off x="731520" y="3931920"/>
+            <a:ext cx="5522975" cy="2743"/>
+          </a:xfrm>
+          <a:prstGeom prst="rect">
+            <a:avLst/>
+          </a:prstGeom>
+          <a:solidFill>
+            <a:srgbClr val="2C2C2E"/>
+          </a:solidFill>
+          <a:ln>
+            <a:noFill/>
+          </a:ln>
+          <a:effectLst/>
+        </p:spPr>
+        <p:style>
+          <a:lnRef idx="1">
+            <a:schemeClr val="accent1"/>
+          </a:lnRef>
+          <a:fillRef idx="3">
+            <a:schemeClr val="accent1"/>
+          </a:fillRef>
+          <a:effectRef idx="2">
+            <a:schemeClr val="accent1"/>
+          </a:effectRef>
+          <a:fontRef idx="minor">
+            <a:schemeClr val="lt1"/>
+          </a:fontRef>
+        </p:style>
+        <p:txBody>
+          <a:bodyPr rtlCol="0" anchor="ctr"/>
+          <a:lstStyle/>
+          <a:p>
+            <a:pPr algn="ctr"/>
+          </a:p>
+        </p:txBody>
+      </p:sp>
       <p:sp>
         <p:nvSpPr>
           <p:cNvPr id="5" name="TextBox 4"/>
@@ -4453,8 +4216,1780 @@
         </p:nvSpPr>
         <p:spPr>
           <a:xfrm>
-            <a:off x="5943600" y="1097280"/>
-            <a:ext cx="2926080" cy="274320"/>
+            <a:off x="137160" y="3840480"/>
+            <a:ext cx="502920" cy="182880"/>
+          </a:xfrm>
+          <a:prstGeom prst="rect">
+            <a:avLst/>
+          </a:prstGeom>
+          <a:noFill/>
+        </p:spPr>
+        <p:txBody>
+          <a:bodyPr wrap="square" tIns="0" bIns="0" lIns="0" rIns="0">
+            <a:spAutoFit/>
+          </a:bodyPr>
+          <a:lstStyle/>
+          <a:p>
+            <a:pPr algn="r">
+              <a:defRPr sz="700" b="0">
+                <a:solidFill>
+                  <a:srgbClr val="6B6B6B"/>
+                </a:solidFill>
+                <a:latin typeface="Inter"/>
+              </a:defRPr>
+            </a:pPr>
+            <a:r>
+              <a:t>0</a:t>
+            </a:r>
+          </a:p>
+        </p:txBody>
+      </p:sp>
+      <p:sp>
+        <p:nvSpPr>
+          <p:cNvPr id="6" name="Rectangle 5"/>
+          <p:cNvSpPr/>
+          <p:nvPr/>
+        </p:nvSpPr>
+        <p:spPr>
+          <a:xfrm>
+            <a:off x="731520" y="3364991"/>
+            <a:ext cx="5522975" cy="2743"/>
+          </a:xfrm>
+          <a:prstGeom prst="rect">
+            <a:avLst/>
+          </a:prstGeom>
+          <a:solidFill>
+            <a:srgbClr val="2C2C2E"/>
+          </a:solidFill>
+          <a:ln>
+            <a:noFill/>
+          </a:ln>
+          <a:effectLst/>
+        </p:spPr>
+        <p:style>
+          <a:lnRef idx="1">
+            <a:schemeClr val="accent1"/>
+          </a:lnRef>
+          <a:fillRef idx="3">
+            <a:schemeClr val="accent1"/>
+          </a:fillRef>
+          <a:effectRef idx="2">
+            <a:schemeClr val="accent1"/>
+          </a:effectRef>
+          <a:fontRef idx="minor">
+            <a:schemeClr val="lt1"/>
+          </a:fontRef>
+        </p:style>
+        <p:txBody>
+          <a:bodyPr rtlCol="0" anchor="ctr"/>
+          <a:lstStyle/>
+          <a:p>
+            <a:pPr algn="ctr"/>
+          </a:p>
+        </p:txBody>
+      </p:sp>
+      <p:sp>
+        <p:nvSpPr>
+          <p:cNvPr id="7" name="TextBox 6"/>
+          <p:cNvSpPr txBox="1"/>
+          <p:nvPr/>
+        </p:nvSpPr>
+        <p:spPr>
+          <a:xfrm>
+            <a:off x="137160" y="3273551"/>
+            <a:ext cx="502920" cy="182880"/>
+          </a:xfrm>
+          <a:prstGeom prst="rect">
+            <a:avLst/>
+          </a:prstGeom>
+          <a:noFill/>
+        </p:spPr>
+        <p:txBody>
+          <a:bodyPr wrap="square" tIns="0" bIns="0" lIns="0" rIns="0">
+            <a:spAutoFit/>
+          </a:bodyPr>
+          <a:lstStyle/>
+          <a:p>
+            <a:pPr algn="r">
+              <a:defRPr sz="700" b="0">
+                <a:solidFill>
+                  <a:srgbClr val="6B6B6B"/>
+                </a:solidFill>
+                <a:latin typeface="Inter"/>
+              </a:defRPr>
+            </a:pPr>
+            <a:r>
+              <a:t>2</a:t>
+            </a:r>
+          </a:p>
+        </p:txBody>
+      </p:sp>
+      <p:sp>
+        <p:nvSpPr>
+          <p:cNvPr id="8" name="Rectangle 7"/>
+          <p:cNvSpPr/>
+          <p:nvPr/>
+        </p:nvSpPr>
+        <p:spPr>
+          <a:xfrm>
+            <a:off x="731520" y="2798063"/>
+            <a:ext cx="5522975" cy="2743"/>
+          </a:xfrm>
+          <a:prstGeom prst="rect">
+            <a:avLst/>
+          </a:prstGeom>
+          <a:solidFill>
+            <a:srgbClr val="2C2C2E"/>
+          </a:solidFill>
+          <a:ln>
+            <a:noFill/>
+          </a:ln>
+          <a:effectLst/>
+        </p:spPr>
+        <p:style>
+          <a:lnRef idx="1">
+            <a:schemeClr val="accent1"/>
+          </a:lnRef>
+          <a:fillRef idx="3">
+            <a:schemeClr val="accent1"/>
+          </a:fillRef>
+          <a:effectRef idx="2">
+            <a:schemeClr val="accent1"/>
+          </a:effectRef>
+          <a:fontRef idx="minor">
+            <a:schemeClr val="lt1"/>
+          </a:fontRef>
+        </p:style>
+        <p:txBody>
+          <a:bodyPr rtlCol="0" anchor="ctr"/>
+          <a:lstStyle/>
+          <a:p>
+            <a:pPr algn="ctr"/>
+          </a:p>
+        </p:txBody>
+      </p:sp>
+      <p:sp>
+        <p:nvSpPr>
+          <p:cNvPr id="9" name="TextBox 8"/>
+          <p:cNvSpPr txBox="1"/>
+          <p:nvPr/>
+        </p:nvSpPr>
+        <p:spPr>
+          <a:xfrm>
+            <a:off x="137160" y="2706623"/>
+            <a:ext cx="502920" cy="182880"/>
+          </a:xfrm>
+          <a:prstGeom prst="rect">
+            <a:avLst/>
+          </a:prstGeom>
+          <a:noFill/>
+        </p:spPr>
+        <p:txBody>
+          <a:bodyPr wrap="square" tIns="0" bIns="0" lIns="0" rIns="0">
+            <a:spAutoFit/>
+          </a:bodyPr>
+          <a:lstStyle/>
+          <a:p>
+            <a:pPr algn="r">
+              <a:defRPr sz="700" b="0">
+                <a:solidFill>
+                  <a:srgbClr val="6B6B6B"/>
+                </a:solidFill>
+                <a:latin typeface="Inter"/>
+              </a:defRPr>
+            </a:pPr>
+            <a:r>
+              <a:t>4</a:t>
+            </a:r>
+          </a:p>
+        </p:txBody>
+      </p:sp>
+      <p:sp>
+        <p:nvSpPr>
+          <p:cNvPr id="10" name="Rectangle 9"/>
+          <p:cNvSpPr/>
+          <p:nvPr/>
+        </p:nvSpPr>
+        <p:spPr>
+          <a:xfrm>
+            <a:off x="731520" y="2231136"/>
+            <a:ext cx="5522975" cy="2743"/>
+          </a:xfrm>
+          <a:prstGeom prst="rect">
+            <a:avLst/>
+          </a:prstGeom>
+          <a:solidFill>
+            <a:srgbClr val="2C2C2E"/>
+          </a:solidFill>
+          <a:ln>
+            <a:noFill/>
+          </a:ln>
+          <a:effectLst/>
+        </p:spPr>
+        <p:style>
+          <a:lnRef idx="1">
+            <a:schemeClr val="accent1"/>
+          </a:lnRef>
+          <a:fillRef idx="3">
+            <a:schemeClr val="accent1"/>
+          </a:fillRef>
+          <a:effectRef idx="2">
+            <a:schemeClr val="accent1"/>
+          </a:effectRef>
+          <a:fontRef idx="minor">
+            <a:schemeClr val="lt1"/>
+          </a:fontRef>
+        </p:style>
+        <p:txBody>
+          <a:bodyPr rtlCol="0" anchor="ctr"/>
+          <a:lstStyle/>
+          <a:p>
+            <a:pPr algn="ctr"/>
+          </a:p>
+        </p:txBody>
+      </p:sp>
+      <p:sp>
+        <p:nvSpPr>
+          <p:cNvPr id="11" name="TextBox 10"/>
+          <p:cNvSpPr txBox="1"/>
+          <p:nvPr/>
+        </p:nvSpPr>
+        <p:spPr>
+          <a:xfrm>
+            <a:off x="137160" y="2139696"/>
+            <a:ext cx="502920" cy="182880"/>
+          </a:xfrm>
+          <a:prstGeom prst="rect">
+            <a:avLst/>
+          </a:prstGeom>
+          <a:noFill/>
+        </p:spPr>
+        <p:txBody>
+          <a:bodyPr wrap="square" tIns="0" bIns="0" lIns="0" rIns="0">
+            <a:spAutoFit/>
+          </a:bodyPr>
+          <a:lstStyle/>
+          <a:p>
+            <a:pPr algn="r">
+              <a:defRPr sz="700" b="0">
+                <a:solidFill>
+                  <a:srgbClr val="6B6B6B"/>
+                </a:solidFill>
+                <a:latin typeface="Inter"/>
+              </a:defRPr>
+            </a:pPr>
+            <a:r>
+              <a:t>6</a:t>
+            </a:r>
+          </a:p>
+        </p:txBody>
+      </p:sp>
+      <p:sp>
+        <p:nvSpPr>
+          <p:cNvPr id="12" name="Rectangle 11"/>
+          <p:cNvSpPr/>
+          <p:nvPr/>
+        </p:nvSpPr>
+        <p:spPr>
+          <a:xfrm>
+            <a:off x="731520" y="1664207"/>
+            <a:ext cx="5522975" cy="2743"/>
+          </a:xfrm>
+          <a:prstGeom prst="rect">
+            <a:avLst/>
+          </a:prstGeom>
+          <a:solidFill>
+            <a:srgbClr val="2C2C2E"/>
+          </a:solidFill>
+          <a:ln>
+            <a:noFill/>
+          </a:ln>
+          <a:effectLst/>
+        </p:spPr>
+        <p:style>
+          <a:lnRef idx="1">
+            <a:schemeClr val="accent1"/>
+          </a:lnRef>
+          <a:fillRef idx="3">
+            <a:schemeClr val="accent1"/>
+          </a:fillRef>
+          <a:effectRef idx="2">
+            <a:schemeClr val="accent1"/>
+          </a:effectRef>
+          <a:fontRef idx="minor">
+            <a:schemeClr val="lt1"/>
+          </a:fontRef>
+        </p:style>
+        <p:txBody>
+          <a:bodyPr rtlCol="0" anchor="ctr"/>
+          <a:lstStyle/>
+          <a:p>
+            <a:pPr algn="ctr"/>
+          </a:p>
+        </p:txBody>
+      </p:sp>
+      <p:sp>
+        <p:nvSpPr>
+          <p:cNvPr id="13" name="TextBox 12"/>
+          <p:cNvSpPr txBox="1"/>
+          <p:nvPr/>
+        </p:nvSpPr>
+        <p:spPr>
+          <a:xfrm>
+            <a:off x="137160" y="1572767"/>
+            <a:ext cx="502920" cy="182880"/>
+          </a:xfrm>
+          <a:prstGeom prst="rect">
+            <a:avLst/>
+          </a:prstGeom>
+          <a:noFill/>
+        </p:spPr>
+        <p:txBody>
+          <a:bodyPr wrap="square" tIns="0" bIns="0" lIns="0" rIns="0">
+            <a:spAutoFit/>
+          </a:bodyPr>
+          <a:lstStyle/>
+          <a:p>
+            <a:pPr algn="r">
+              <a:defRPr sz="700" b="0">
+                <a:solidFill>
+                  <a:srgbClr val="6B6B6B"/>
+                </a:solidFill>
+                <a:latin typeface="Inter"/>
+              </a:defRPr>
+            </a:pPr>
+            <a:r>
+              <a:t>8</a:t>
+            </a:r>
+          </a:p>
+        </p:txBody>
+      </p:sp>
+      <p:sp>
+        <p:nvSpPr>
+          <p:cNvPr id="14" name="Rectangle 13"/>
+          <p:cNvSpPr/>
+          <p:nvPr/>
+        </p:nvSpPr>
+        <p:spPr>
+          <a:xfrm>
+            <a:off x="731520" y="1097280"/>
+            <a:ext cx="5522975" cy="2743"/>
+          </a:xfrm>
+          <a:prstGeom prst="rect">
+            <a:avLst/>
+          </a:prstGeom>
+          <a:solidFill>
+            <a:srgbClr val="2C2C2E"/>
+          </a:solidFill>
+          <a:ln>
+            <a:noFill/>
+          </a:ln>
+          <a:effectLst/>
+        </p:spPr>
+        <p:style>
+          <a:lnRef idx="1">
+            <a:schemeClr val="accent1"/>
+          </a:lnRef>
+          <a:fillRef idx="3">
+            <a:schemeClr val="accent1"/>
+          </a:fillRef>
+          <a:effectRef idx="2">
+            <a:schemeClr val="accent1"/>
+          </a:effectRef>
+          <a:fontRef idx="minor">
+            <a:schemeClr val="lt1"/>
+          </a:fontRef>
+        </p:style>
+        <p:txBody>
+          <a:bodyPr rtlCol="0" anchor="ctr"/>
+          <a:lstStyle/>
+          <a:p>
+            <a:pPr algn="ctr"/>
+          </a:p>
+        </p:txBody>
+      </p:sp>
+      <p:sp>
+        <p:nvSpPr>
+          <p:cNvPr id="15" name="TextBox 14"/>
+          <p:cNvSpPr txBox="1"/>
+          <p:nvPr/>
+        </p:nvSpPr>
+        <p:spPr>
+          <a:xfrm>
+            <a:off x="137160" y="1005840"/>
+            <a:ext cx="502920" cy="182880"/>
+          </a:xfrm>
+          <a:prstGeom prst="rect">
+            <a:avLst/>
+          </a:prstGeom>
+          <a:noFill/>
+        </p:spPr>
+        <p:txBody>
+          <a:bodyPr wrap="square" tIns="0" bIns="0" lIns="0" rIns="0">
+            <a:spAutoFit/>
+          </a:bodyPr>
+          <a:lstStyle/>
+          <a:p>
+            <a:pPr algn="r">
+              <a:defRPr sz="700" b="0">
+                <a:solidFill>
+                  <a:srgbClr val="6B6B6B"/>
+                </a:solidFill>
+                <a:latin typeface="Inter"/>
+              </a:defRPr>
+            </a:pPr>
+            <a:r>
+              <a:t>10</a:t>
+            </a:r>
+          </a:p>
+        </p:txBody>
+      </p:sp>
+      <p:sp>
+        <p:nvSpPr>
+          <p:cNvPr id="16" name="Rounded Rectangle 15"/>
+          <p:cNvSpPr/>
+          <p:nvPr/>
+        </p:nvSpPr>
+        <p:spPr>
+          <a:xfrm>
+            <a:off x="731520" y="1097280"/>
+            <a:ext cx="320040" cy="2834639"/>
+          </a:xfrm>
+          <a:prstGeom prst="roundRect">
+            <a:avLst/>
+          </a:prstGeom>
+          <a:solidFill>
+            <a:srgbClr val="5A5A5E"/>
+          </a:solidFill>
+          <a:ln>
+            <a:noFill/>
+          </a:ln>
+          <a:effectLst/>
+        </p:spPr>
+        <p:style>
+          <a:lnRef idx="1">
+            <a:schemeClr val="accent1"/>
+          </a:lnRef>
+          <a:fillRef idx="3">
+            <a:schemeClr val="accent1"/>
+          </a:fillRef>
+          <a:effectRef idx="2">
+            <a:schemeClr val="accent1"/>
+          </a:effectRef>
+          <a:fontRef idx="minor">
+            <a:schemeClr val="lt1"/>
+          </a:fontRef>
+        </p:style>
+        <p:txBody>
+          <a:bodyPr rtlCol="0" anchor="ctr"/>
+          <a:lstStyle/>
+          <a:p>
+            <a:pPr algn="ctr"/>
+          </a:p>
+        </p:txBody>
+      </p:sp>
+      <p:sp>
+        <p:nvSpPr>
+          <p:cNvPr id="17" name="Rounded Rectangle 16"/>
+          <p:cNvSpPr/>
+          <p:nvPr/>
+        </p:nvSpPr>
+        <p:spPr>
+          <a:xfrm>
+            <a:off x="1088136" y="1380744"/>
+            <a:ext cx="320040" cy="2551175"/>
+          </a:xfrm>
+          <a:prstGeom prst="roundRect">
+            <a:avLst/>
+          </a:prstGeom>
+          <a:solidFill>
+            <a:srgbClr val="0066FF"/>
+          </a:solidFill>
+          <a:ln>
+            <a:noFill/>
+          </a:ln>
+          <a:effectLst/>
+        </p:spPr>
+        <p:style>
+          <a:lnRef idx="1">
+            <a:schemeClr val="accent1"/>
+          </a:lnRef>
+          <a:fillRef idx="3">
+            <a:schemeClr val="accent1"/>
+          </a:fillRef>
+          <a:effectRef idx="2">
+            <a:schemeClr val="accent1"/>
+          </a:effectRef>
+          <a:fontRef idx="minor">
+            <a:schemeClr val="lt1"/>
+          </a:fontRef>
+        </p:style>
+        <p:txBody>
+          <a:bodyPr rtlCol="0" anchor="ctr"/>
+          <a:lstStyle/>
+          <a:p>
+            <a:pPr algn="ctr"/>
+          </a:p>
+        </p:txBody>
+      </p:sp>
+      <p:sp>
+        <p:nvSpPr>
+          <p:cNvPr id="18" name="TextBox 17"/>
+          <p:cNvSpPr txBox="1"/>
+          <p:nvPr/>
+        </p:nvSpPr>
+        <p:spPr>
+          <a:xfrm>
+            <a:off x="731520" y="896112"/>
+            <a:ext cx="320040" cy="182880"/>
+          </a:xfrm>
+          <a:prstGeom prst="rect">
+            <a:avLst/>
+          </a:prstGeom>
+          <a:noFill/>
+        </p:spPr>
+        <p:txBody>
+          <a:bodyPr wrap="square" tIns="0" bIns="0" lIns="0" rIns="0">
+            <a:spAutoFit/>
+          </a:bodyPr>
+          <a:lstStyle/>
+          <a:p>
+            <a:pPr algn="ctr">
+              <a:defRPr sz="700" b="1">
+                <a:solidFill>
+                  <a:srgbClr val="A0A0A0"/>
+                </a:solidFill>
+                <a:latin typeface="Inter"/>
+              </a:defRPr>
+            </a:pPr>
+            <a:r>
+              <a:t>10</a:t>
+            </a:r>
+          </a:p>
+        </p:txBody>
+      </p:sp>
+      <p:sp>
+        <p:nvSpPr>
+          <p:cNvPr id="19" name="TextBox 18"/>
+          <p:cNvSpPr txBox="1"/>
+          <p:nvPr/>
+        </p:nvSpPr>
+        <p:spPr>
+          <a:xfrm>
+            <a:off x="1088136" y="1179576"/>
+            <a:ext cx="320040" cy="182880"/>
+          </a:xfrm>
+          <a:prstGeom prst="rect">
+            <a:avLst/>
+          </a:prstGeom>
+          <a:noFill/>
+        </p:spPr>
+        <p:txBody>
+          <a:bodyPr wrap="square" tIns="0" bIns="0" lIns="0" rIns="0">
+            <a:spAutoFit/>
+          </a:bodyPr>
+          <a:lstStyle/>
+          <a:p>
+            <a:pPr algn="ctr">
+              <a:defRPr sz="700" b="1">
+                <a:solidFill>
+                  <a:srgbClr val="4A8AFF"/>
+                </a:solidFill>
+                <a:latin typeface="Inter"/>
+              </a:defRPr>
+            </a:pPr>
+            <a:r>
+              <a:t>9</a:t>
+            </a:r>
+          </a:p>
+        </p:txBody>
+      </p:sp>
+      <p:sp>
+        <p:nvSpPr>
+          <p:cNvPr id="20" name="TextBox 19"/>
+          <p:cNvSpPr txBox="1"/>
+          <p:nvPr/>
+        </p:nvSpPr>
+        <p:spPr>
+          <a:xfrm>
+            <a:off x="685800" y="4005072"/>
+            <a:ext cx="768096" cy="274320"/>
+          </a:xfrm>
+          <a:prstGeom prst="rect">
+            <a:avLst/>
+          </a:prstGeom>
+          <a:noFill/>
+        </p:spPr>
+        <p:txBody>
+          <a:bodyPr wrap="square" tIns="0" bIns="0" lIns="0" rIns="0">
+            <a:spAutoFit/>
+          </a:bodyPr>
+          <a:lstStyle/>
+          <a:p>
+            <a:pPr algn="ctr">
+              <a:defRPr sz="700" b="0">
+                <a:solidFill>
+                  <a:srgbClr val="A0A0A0"/>
+                </a:solidFill>
+                <a:latin typeface="Inter"/>
+              </a:defRPr>
+            </a:pPr>
+            <a:r>
+              <a:t>Product strategy</a:t>
+            </a:r>
+          </a:p>
+        </p:txBody>
+      </p:sp>
+      <p:sp>
+        <p:nvSpPr>
+          <p:cNvPr id="21" name="Rounded Rectangle 20"/>
+          <p:cNvSpPr/>
+          <p:nvPr/>
+        </p:nvSpPr>
+        <p:spPr>
+          <a:xfrm>
+            <a:off x="1700784" y="1097280"/>
+            <a:ext cx="320040" cy="2834639"/>
+          </a:xfrm>
+          <a:prstGeom prst="roundRect">
+            <a:avLst/>
+          </a:prstGeom>
+          <a:solidFill>
+            <a:srgbClr val="5A5A5E"/>
+          </a:solidFill>
+          <a:ln>
+            <a:noFill/>
+          </a:ln>
+          <a:effectLst/>
+        </p:spPr>
+        <p:style>
+          <a:lnRef idx="1">
+            <a:schemeClr val="accent1"/>
+          </a:lnRef>
+          <a:fillRef idx="3">
+            <a:schemeClr val="accent1"/>
+          </a:fillRef>
+          <a:effectRef idx="2">
+            <a:schemeClr val="accent1"/>
+          </a:effectRef>
+          <a:fontRef idx="minor">
+            <a:schemeClr val="lt1"/>
+          </a:fontRef>
+        </p:style>
+        <p:txBody>
+          <a:bodyPr rtlCol="0" anchor="ctr"/>
+          <a:lstStyle/>
+          <a:p>
+            <a:pPr algn="ctr"/>
+          </a:p>
+        </p:txBody>
+      </p:sp>
+      <p:sp>
+        <p:nvSpPr>
+          <p:cNvPr id="22" name="Rounded Rectangle 21"/>
+          <p:cNvSpPr/>
+          <p:nvPr/>
+        </p:nvSpPr>
+        <p:spPr>
+          <a:xfrm>
+            <a:off x="2057400" y="1380744"/>
+            <a:ext cx="320040" cy="2551175"/>
+          </a:xfrm>
+          <a:prstGeom prst="roundRect">
+            <a:avLst/>
+          </a:prstGeom>
+          <a:solidFill>
+            <a:srgbClr val="0066FF"/>
+          </a:solidFill>
+          <a:ln>
+            <a:noFill/>
+          </a:ln>
+          <a:effectLst/>
+        </p:spPr>
+        <p:style>
+          <a:lnRef idx="1">
+            <a:schemeClr val="accent1"/>
+          </a:lnRef>
+          <a:fillRef idx="3">
+            <a:schemeClr val="accent1"/>
+          </a:fillRef>
+          <a:effectRef idx="2">
+            <a:schemeClr val="accent1"/>
+          </a:effectRef>
+          <a:fontRef idx="minor">
+            <a:schemeClr val="lt1"/>
+          </a:fontRef>
+        </p:style>
+        <p:txBody>
+          <a:bodyPr rtlCol="0" anchor="ctr"/>
+          <a:lstStyle/>
+          <a:p>
+            <a:pPr algn="ctr"/>
+          </a:p>
+        </p:txBody>
+      </p:sp>
+      <p:sp>
+        <p:nvSpPr>
+          <p:cNvPr id="23" name="TextBox 22"/>
+          <p:cNvSpPr txBox="1"/>
+          <p:nvPr/>
+        </p:nvSpPr>
+        <p:spPr>
+          <a:xfrm>
+            <a:off x="1700784" y="896112"/>
+            <a:ext cx="320040" cy="182880"/>
+          </a:xfrm>
+          <a:prstGeom prst="rect">
+            <a:avLst/>
+          </a:prstGeom>
+          <a:noFill/>
+        </p:spPr>
+        <p:txBody>
+          <a:bodyPr wrap="square" tIns="0" bIns="0" lIns="0" rIns="0">
+            <a:spAutoFit/>
+          </a:bodyPr>
+          <a:lstStyle/>
+          <a:p>
+            <a:pPr algn="ctr">
+              <a:defRPr sz="700" b="1">
+                <a:solidFill>
+                  <a:srgbClr val="A0A0A0"/>
+                </a:solidFill>
+                <a:latin typeface="Inter"/>
+              </a:defRPr>
+            </a:pPr>
+            <a:r>
+              <a:t>10</a:t>
+            </a:r>
+          </a:p>
+        </p:txBody>
+      </p:sp>
+      <p:sp>
+        <p:nvSpPr>
+          <p:cNvPr id="24" name="TextBox 23"/>
+          <p:cNvSpPr txBox="1"/>
+          <p:nvPr/>
+        </p:nvSpPr>
+        <p:spPr>
+          <a:xfrm>
+            <a:off x="2057400" y="1179576"/>
+            <a:ext cx="320040" cy="182880"/>
+          </a:xfrm>
+          <a:prstGeom prst="rect">
+            <a:avLst/>
+          </a:prstGeom>
+          <a:noFill/>
+        </p:spPr>
+        <p:txBody>
+          <a:bodyPr wrap="square" tIns="0" bIns="0" lIns="0" rIns="0">
+            <a:spAutoFit/>
+          </a:bodyPr>
+          <a:lstStyle/>
+          <a:p>
+            <a:pPr algn="ctr">
+              <a:defRPr sz="700" b="1">
+                <a:solidFill>
+                  <a:srgbClr val="4A8AFF"/>
+                </a:solidFill>
+                <a:latin typeface="Inter"/>
+              </a:defRPr>
+            </a:pPr>
+            <a:r>
+              <a:t>9</a:t>
+            </a:r>
+          </a:p>
+        </p:txBody>
+      </p:sp>
+      <p:sp>
+        <p:nvSpPr>
+          <p:cNvPr id="25" name="TextBox 24"/>
+          <p:cNvSpPr txBox="1"/>
+          <p:nvPr/>
+        </p:nvSpPr>
+        <p:spPr>
+          <a:xfrm>
+            <a:off x="1655064" y="4005072"/>
+            <a:ext cx="768096" cy="274320"/>
+          </a:xfrm>
+          <a:prstGeom prst="rect">
+            <a:avLst/>
+          </a:prstGeom>
+          <a:noFill/>
+        </p:spPr>
+        <p:txBody>
+          <a:bodyPr wrap="square" tIns="0" bIns="0" lIns="0" rIns="0">
+            <a:spAutoFit/>
+          </a:bodyPr>
+          <a:lstStyle/>
+          <a:p>
+            <a:pPr algn="ctr">
+              <a:defRPr sz="700" b="0">
+                <a:solidFill>
+                  <a:srgbClr val="A0A0A0"/>
+                </a:solidFill>
+                <a:latin typeface="Inter"/>
+              </a:defRPr>
+            </a:pPr>
+            <a:r>
+              <a:t>Data &amp; insights</a:t>
+            </a:r>
+          </a:p>
+        </p:txBody>
+      </p:sp>
+      <p:sp>
+        <p:nvSpPr>
+          <p:cNvPr id="26" name="Rounded Rectangle 25"/>
+          <p:cNvSpPr/>
+          <p:nvPr/>
+        </p:nvSpPr>
+        <p:spPr>
+          <a:xfrm>
+            <a:off x="2670048" y="1097280"/>
+            <a:ext cx="320040" cy="2834639"/>
+          </a:xfrm>
+          <a:prstGeom prst="roundRect">
+            <a:avLst/>
+          </a:prstGeom>
+          <a:solidFill>
+            <a:srgbClr val="5A5A5E"/>
+          </a:solidFill>
+          <a:ln>
+            <a:noFill/>
+          </a:ln>
+          <a:effectLst/>
+        </p:spPr>
+        <p:style>
+          <a:lnRef idx="1">
+            <a:schemeClr val="accent1"/>
+          </a:lnRef>
+          <a:fillRef idx="3">
+            <a:schemeClr val="accent1"/>
+          </a:fillRef>
+          <a:effectRef idx="2">
+            <a:schemeClr val="accent1"/>
+          </a:effectRef>
+          <a:fontRef idx="minor">
+            <a:schemeClr val="lt1"/>
+          </a:fontRef>
+        </p:style>
+        <p:txBody>
+          <a:bodyPr rtlCol="0" anchor="ctr"/>
+          <a:lstStyle/>
+          <a:p>
+            <a:pPr algn="ctr"/>
+          </a:p>
+        </p:txBody>
+      </p:sp>
+      <p:sp>
+        <p:nvSpPr>
+          <p:cNvPr id="27" name="Rounded Rectangle 26"/>
+          <p:cNvSpPr/>
+          <p:nvPr/>
+        </p:nvSpPr>
+        <p:spPr>
+          <a:xfrm>
+            <a:off x="3026664" y="1097280"/>
+            <a:ext cx="320040" cy="2834639"/>
+          </a:xfrm>
+          <a:prstGeom prst="roundRect">
+            <a:avLst/>
+          </a:prstGeom>
+          <a:solidFill>
+            <a:srgbClr val="0066FF"/>
+          </a:solidFill>
+          <a:ln>
+            <a:noFill/>
+          </a:ln>
+          <a:effectLst/>
+        </p:spPr>
+        <p:style>
+          <a:lnRef idx="1">
+            <a:schemeClr val="accent1"/>
+          </a:lnRef>
+          <a:fillRef idx="3">
+            <a:schemeClr val="accent1"/>
+          </a:fillRef>
+          <a:effectRef idx="2">
+            <a:schemeClr val="accent1"/>
+          </a:effectRef>
+          <a:fontRef idx="minor">
+            <a:schemeClr val="lt1"/>
+          </a:fontRef>
+        </p:style>
+        <p:txBody>
+          <a:bodyPr rtlCol="0" anchor="ctr"/>
+          <a:lstStyle/>
+          <a:p>
+            <a:pPr algn="ctr"/>
+          </a:p>
+        </p:txBody>
+      </p:sp>
+      <p:sp>
+        <p:nvSpPr>
+          <p:cNvPr id="28" name="TextBox 27"/>
+          <p:cNvSpPr txBox="1"/>
+          <p:nvPr/>
+        </p:nvSpPr>
+        <p:spPr>
+          <a:xfrm>
+            <a:off x="2670048" y="896112"/>
+            <a:ext cx="320040" cy="182880"/>
+          </a:xfrm>
+          <a:prstGeom prst="rect">
+            <a:avLst/>
+          </a:prstGeom>
+          <a:noFill/>
+        </p:spPr>
+        <p:txBody>
+          <a:bodyPr wrap="square" tIns="0" bIns="0" lIns="0" rIns="0">
+            <a:spAutoFit/>
+          </a:bodyPr>
+          <a:lstStyle/>
+          <a:p>
+            <a:pPr algn="ctr">
+              <a:defRPr sz="700" b="1">
+                <a:solidFill>
+                  <a:srgbClr val="A0A0A0"/>
+                </a:solidFill>
+                <a:latin typeface="Inter"/>
+              </a:defRPr>
+            </a:pPr>
+            <a:r>
+              <a:t>10</a:t>
+            </a:r>
+          </a:p>
+        </p:txBody>
+      </p:sp>
+      <p:sp>
+        <p:nvSpPr>
+          <p:cNvPr id="29" name="TextBox 28"/>
+          <p:cNvSpPr txBox="1"/>
+          <p:nvPr/>
+        </p:nvSpPr>
+        <p:spPr>
+          <a:xfrm>
+            <a:off x="3026664" y="896112"/>
+            <a:ext cx="320040" cy="182880"/>
+          </a:xfrm>
+          <a:prstGeom prst="rect">
+            <a:avLst/>
+          </a:prstGeom>
+          <a:noFill/>
+        </p:spPr>
+        <p:txBody>
+          <a:bodyPr wrap="square" tIns="0" bIns="0" lIns="0" rIns="0">
+            <a:spAutoFit/>
+          </a:bodyPr>
+          <a:lstStyle/>
+          <a:p>
+            <a:pPr algn="ctr">
+              <a:defRPr sz="700" b="1">
+                <a:solidFill>
+                  <a:srgbClr val="4A8AFF"/>
+                </a:solidFill>
+                <a:latin typeface="Inter"/>
+              </a:defRPr>
+            </a:pPr>
+            <a:r>
+              <a:t>10</a:t>
+            </a:r>
+          </a:p>
+        </p:txBody>
+      </p:sp>
+      <p:sp>
+        <p:nvSpPr>
+          <p:cNvPr id="30" name="TextBox 29"/>
+          <p:cNvSpPr txBox="1"/>
+          <p:nvPr/>
+        </p:nvSpPr>
+        <p:spPr>
+          <a:xfrm>
+            <a:off x="2624328" y="4005072"/>
+            <a:ext cx="768096" cy="274320"/>
+          </a:xfrm>
+          <a:prstGeom prst="rect">
+            <a:avLst/>
+          </a:prstGeom>
+          <a:noFill/>
+        </p:spPr>
+        <p:txBody>
+          <a:bodyPr wrap="square" tIns="0" bIns="0" lIns="0" rIns="0">
+            <a:spAutoFit/>
+          </a:bodyPr>
+          <a:lstStyle/>
+          <a:p>
+            <a:pPr algn="ctr">
+              <a:defRPr sz="700" b="0">
+                <a:solidFill>
+                  <a:srgbClr val="A0A0A0"/>
+                </a:solidFill>
+                <a:latin typeface="Inter"/>
+              </a:defRPr>
+            </a:pPr>
+            <a:r>
+              <a:t>Cross-functional</a:t>
+            </a:r>
+          </a:p>
+        </p:txBody>
+      </p:sp>
+      <p:sp>
+        <p:nvSpPr>
+          <p:cNvPr id="31" name="Rounded Rectangle 30"/>
+          <p:cNvSpPr/>
+          <p:nvPr/>
+        </p:nvSpPr>
+        <p:spPr>
+          <a:xfrm>
+            <a:off x="3639312" y="1097280"/>
+            <a:ext cx="320040" cy="2834639"/>
+          </a:xfrm>
+          <a:prstGeom prst="roundRect">
+            <a:avLst/>
+          </a:prstGeom>
+          <a:solidFill>
+            <a:srgbClr val="5A5A5E"/>
+          </a:solidFill>
+          <a:ln>
+            <a:noFill/>
+          </a:ln>
+          <a:effectLst/>
+        </p:spPr>
+        <p:style>
+          <a:lnRef idx="1">
+            <a:schemeClr val="accent1"/>
+          </a:lnRef>
+          <a:fillRef idx="3">
+            <a:schemeClr val="accent1"/>
+          </a:fillRef>
+          <a:effectRef idx="2">
+            <a:schemeClr val="accent1"/>
+          </a:effectRef>
+          <a:fontRef idx="minor">
+            <a:schemeClr val="lt1"/>
+          </a:fontRef>
+        </p:style>
+        <p:txBody>
+          <a:bodyPr rtlCol="0" anchor="ctr"/>
+          <a:lstStyle/>
+          <a:p>
+            <a:pPr algn="ctr"/>
+          </a:p>
+        </p:txBody>
+      </p:sp>
+      <p:sp>
+        <p:nvSpPr>
+          <p:cNvPr id="32" name="Rounded Rectangle 31"/>
+          <p:cNvSpPr/>
+          <p:nvPr/>
+        </p:nvSpPr>
+        <p:spPr>
+          <a:xfrm>
+            <a:off x="3995928" y="1664207"/>
+            <a:ext cx="320040" cy="2267712"/>
+          </a:xfrm>
+          <a:prstGeom prst="roundRect">
+            <a:avLst/>
+          </a:prstGeom>
+          <a:solidFill>
+            <a:srgbClr val="0066FF"/>
+          </a:solidFill>
+          <a:ln>
+            <a:noFill/>
+          </a:ln>
+          <a:effectLst/>
+        </p:spPr>
+        <p:style>
+          <a:lnRef idx="1">
+            <a:schemeClr val="accent1"/>
+          </a:lnRef>
+          <a:fillRef idx="3">
+            <a:schemeClr val="accent1"/>
+          </a:fillRef>
+          <a:effectRef idx="2">
+            <a:schemeClr val="accent1"/>
+          </a:effectRef>
+          <a:fontRef idx="minor">
+            <a:schemeClr val="lt1"/>
+          </a:fontRef>
+        </p:style>
+        <p:txBody>
+          <a:bodyPr rtlCol="0" anchor="ctr"/>
+          <a:lstStyle/>
+          <a:p>
+            <a:pPr algn="ctr"/>
+          </a:p>
+        </p:txBody>
+      </p:sp>
+      <p:sp>
+        <p:nvSpPr>
+          <p:cNvPr id="33" name="TextBox 32"/>
+          <p:cNvSpPr txBox="1"/>
+          <p:nvPr/>
+        </p:nvSpPr>
+        <p:spPr>
+          <a:xfrm>
+            <a:off x="3639312" y="896112"/>
+            <a:ext cx="320040" cy="182880"/>
+          </a:xfrm>
+          <a:prstGeom prst="rect">
+            <a:avLst/>
+          </a:prstGeom>
+          <a:noFill/>
+        </p:spPr>
+        <p:txBody>
+          <a:bodyPr wrap="square" tIns="0" bIns="0" lIns="0" rIns="0">
+            <a:spAutoFit/>
+          </a:bodyPr>
+          <a:lstStyle/>
+          <a:p>
+            <a:pPr algn="ctr">
+              <a:defRPr sz="700" b="1">
+                <a:solidFill>
+                  <a:srgbClr val="A0A0A0"/>
+                </a:solidFill>
+                <a:latin typeface="Inter"/>
+              </a:defRPr>
+            </a:pPr>
+            <a:r>
+              <a:t>10</a:t>
+            </a:r>
+          </a:p>
+        </p:txBody>
+      </p:sp>
+      <p:sp>
+        <p:nvSpPr>
+          <p:cNvPr id="34" name="TextBox 33"/>
+          <p:cNvSpPr txBox="1"/>
+          <p:nvPr/>
+        </p:nvSpPr>
+        <p:spPr>
+          <a:xfrm>
+            <a:off x="3995928" y="1463039"/>
+            <a:ext cx="320040" cy="182880"/>
+          </a:xfrm>
+          <a:prstGeom prst="rect">
+            <a:avLst/>
+          </a:prstGeom>
+          <a:noFill/>
+        </p:spPr>
+        <p:txBody>
+          <a:bodyPr wrap="square" tIns="0" bIns="0" lIns="0" rIns="0">
+            <a:spAutoFit/>
+          </a:bodyPr>
+          <a:lstStyle/>
+          <a:p>
+            <a:pPr algn="ctr">
+              <a:defRPr sz="700" b="1">
+                <a:solidFill>
+                  <a:srgbClr val="4A8AFF"/>
+                </a:solidFill>
+                <a:latin typeface="Inter"/>
+              </a:defRPr>
+            </a:pPr>
+            <a:r>
+              <a:t>8</a:t>
+            </a:r>
+          </a:p>
+        </p:txBody>
+      </p:sp>
+      <p:sp>
+        <p:nvSpPr>
+          <p:cNvPr id="35" name="TextBox 34"/>
+          <p:cNvSpPr txBox="1"/>
+          <p:nvPr/>
+        </p:nvSpPr>
+        <p:spPr>
+          <a:xfrm>
+            <a:off x="3593592" y="4005072"/>
+            <a:ext cx="768096" cy="274320"/>
+          </a:xfrm>
+          <a:prstGeom prst="rect">
+            <a:avLst/>
+          </a:prstGeom>
+          <a:noFill/>
+        </p:spPr>
+        <p:txBody>
+          <a:bodyPr wrap="square" tIns="0" bIns="0" lIns="0" rIns="0">
+            <a:spAutoFit/>
+          </a:bodyPr>
+          <a:lstStyle/>
+          <a:p>
+            <a:pPr algn="ctr">
+              <a:defRPr sz="700" b="0">
+                <a:solidFill>
+                  <a:srgbClr val="A0A0A0"/>
+                </a:solidFill>
+                <a:latin typeface="Inter"/>
+              </a:defRPr>
+            </a:pPr>
+            <a:r>
+              <a:t>User testing</a:t>
+            </a:r>
+          </a:p>
+        </p:txBody>
+      </p:sp>
+      <p:sp>
+        <p:nvSpPr>
+          <p:cNvPr id="36" name="Rounded Rectangle 35"/>
+          <p:cNvSpPr/>
+          <p:nvPr/>
+        </p:nvSpPr>
+        <p:spPr>
+          <a:xfrm>
+            <a:off x="4608576" y="1097280"/>
+            <a:ext cx="320040" cy="2834639"/>
+          </a:xfrm>
+          <a:prstGeom prst="roundRect">
+            <a:avLst/>
+          </a:prstGeom>
+          <a:solidFill>
+            <a:srgbClr val="5A5A5E"/>
+          </a:solidFill>
+          <a:ln>
+            <a:noFill/>
+          </a:ln>
+          <a:effectLst/>
+        </p:spPr>
+        <p:style>
+          <a:lnRef idx="1">
+            <a:schemeClr val="accent1"/>
+          </a:lnRef>
+          <a:fillRef idx="3">
+            <a:schemeClr val="accent1"/>
+          </a:fillRef>
+          <a:effectRef idx="2">
+            <a:schemeClr val="accent1"/>
+          </a:effectRef>
+          <a:fontRef idx="minor">
+            <a:schemeClr val="lt1"/>
+          </a:fontRef>
+        </p:style>
+        <p:txBody>
+          <a:bodyPr rtlCol="0" anchor="ctr"/>
+          <a:lstStyle/>
+          <a:p>
+            <a:pPr algn="ctr"/>
+          </a:p>
+        </p:txBody>
+      </p:sp>
+      <p:sp>
+        <p:nvSpPr>
+          <p:cNvPr id="37" name="Rounded Rectangle 36"/>
+          <p:cNvSpPr/>
+          <p:nvPr/>
+        </p:nvSpPr>
+        <p:spPr>
+          <a:xfrm>
+            <a:off x="4965192" y="1380744"/>
+            <a:ext cx="320040" cy="2551175"/>
+          </a:xfrm>
+          <a:prstGeom prst="roundRect">
+            <a:avLst/>
+          </a:prstGeom>
+          <a:solidFill>
+            <a:srgbClr val="0066FF"/>
+          </a:solidFill>
+          <a:ln>
+            <a:noFill/>
+          </a:ln>
+          <a:effectLst/>
+        </p:spPr>
+        <p:style>
+          <a:lnRef idx="1">
+            <a:schemeClr val="accent1"/>
+          </a:lnRef>
+          <a:fillRef idx="3">
+            <a:schemeClr val="accent1"/>
+          </a:fillRef>
+          <a:effectRef idx="2">
+            <a:schemeClr val="accent1"/>
+          </a:effectRef>
+          <a:fontRef idx="minor">
+            <a:schemeClr val="lt1"/>
+          </a:fontRef>
+        </p:style>
+        <p:txBody>
+          <a:bodyPr rtlCol="0" anchor="ctr"/>
+          <a:lstStyle/>
+          <a:p>
+            <a:pPr algn="ctr"/>
+          </a:p>
+        </p:txBody>
+      </p:sp>
+      <p:sp>
+        <p:nvSpPr>
+          <p:cNvPr id="38" name="TextBox 37"/>
+          <p:cNvSpPr txBox="1"/>
+          <p:nvPr/>
+        </p:nvSpPr>
+        <p:spPr>
+          <a:xfrm>
+            <a:off x="4608576" y="896112"/>
+            <a:ext cx="320040" cy="182880"/>
+          </a:xfrm>
+          <a:prstGeom prst="rect">
+            <a:avLst/>
+          </a:prstGeom>
+          <a:noFill/>
+        </p:spPr>
+        <p:txBody>
+          <a:bodyPr wrap="square" tIns="0" bIns="0" lIns="0" rIns="0">
+            <a:spAutoFit/>
+          </a:bodyPr>
+          <a:lstStyle/>
+          <a:p>
+            <a:pPr algn="ctr">
+              <a:defRPr sz="700" b="1">
+                <a:solidFill>
+                  <a:srgbClr val="A0A0A0"/>
+                </a:solidFill>
+                <a:latin typeface="Inter"/>
+              </a:defRPr>
+            </a:pPr>
+            <a:r>
+              <a:t>10</a:t>
+            </a:r>
+          </a:p>
+        </p:txBody>
+      </p:sp>
+      <p:sp>
+        <p:nvSpPr>
+          <p:cNvPr id="39" name="TextBox 38"/>
+          <p:cNvSpPr txBox="1"/>
+          <p:nvPr/>
+        </p:nvSpPr>
+        <p:spPr>
+          <a:xfrm>
+            <a:off x="4965192" y="1179576"/>
+            <a:ext cx="320040" cy="182880"/>
+          </a:xfrm>
+          <a:prstGeom prst="rect">
+            <a:avLst/>
+          </a:prstGeom>
+          <a:noFill/>
+        </p:spPr>
+        <p:txBody>
+          <a:bodyPr wrap="square" tIns="0" bIns="0" lIns="0" rIns="0">
+            <a:spAutoFit/>
+          </a:bodyPr>
+          <a:lstStyle/>
+          <a:p>
+            <a:pPr algn="ctr">
+              <a:defRPr sz="700" b="1">
+                <a:solidFill>
+                  <a:srgbClr val="4A8AFF"/>
+                </a:solidFill>
+                <a:latin typeface="Inter"/>
+              </a:defRPr>
+            </a:pPr>
+            <a:r>
+              <a:t>9</a:t>
+            </a:r>
+          </a:p>
+        </p:txBody>
+      </p:sp>
+      <p:sp>
+        <p:nvSpPr>
+          <p:cNvPr id="40" name="TextBox 39"/>
+          <p:cNvSpPr txBox="1"/>
+          <p:nvPr/>
+        </p:nvSpPr>
+        <p:spPr>
+          <a:xfrm>
+            <a:off x="4562856" y="4005072"/>
+            <a:ext cx="768096" cy="274320"/>
+          </a:xfrm>
+          <a:prstGeom prst="rect">
+            <a:avLst/>
+          </a:prstGeom>
+          <a:noFill/>
+        </p:spPr>
+        <p:txBody>
+          <a:bodyPr wrap="square" tIns="0" bIns="0" lIns="0" rIns="0">
+            <a:spAutoFit/>
+          </a:bodyPr>
+          <a:lstStyle/>
+          <a:p>
+            <a:pPr algn="ctr">
+              <a:defRPr sz="700" b="0">
+                <a:solidFill>
+                  <a:srgbClr val="A0A0A0"/>
+                </a:solidFill>
+                <a:latin typeface="Inter"/>
+              </a:defRPr>
+            </a:pPr>
+            <a:r>
+              <a:t>Communication</a:t>
+            </a:r>
+          </a:p>
+        </p:txBody>
+      </p:sp>
+      <p:sp>
+        <p:nvSpPr>
+          <p:cNvPr id="41" name="Rounded Rectangle 40"/>
+          <p:cNvSpPr/>
+          <p:nvPr/>
+        </p:nvSpPr>
+        <p:spPr>
+          <a:xfrm>
+            <a:off x="5577840" y="2514600"/>
+            <a:ext cx="320040" cy="1417319"/>
+          </a:xfrm>
+          <a:prstGeom prst="roundRect">
+            <a:avLst/>
+          </a:prstGeom>
+          <a:solidFill>
+            <a:srgbClr val="5A5A5E"/>
+          </a:solidFill>
+          <a:ln>
+            <a:noFill/>
+          </a:ln>
+          <a:effectLst/>
+        </p:spPr>
+        <p:style>
+          <a:lnRef idx="1">
+            <a:schemeClr val="accent1"/>
+          </a:lnRef>
+          <a:fillRef idx="3">
+            <a:schemeClr val="accent1"/>
+          </a:fillRef>
+          <a:effectRef idx="2">
+            <a:schemeClr val="accent1"/>
+          </a:effectRef>
+          <a:fontRef idx="minor">
+            <a:schemeClr val="lt1"/>
+          </a:fontRef>
+        </p:style>
+        <p:txBody>
+          <a:bodyPr rtlCol="0" anchor="ctr"/>
+          <a:lstStyle/>
+          <a:p>
+            <a:pPr algn="ctr"/>
+          </a:p>
+        </p:txBody>
+      </p:sp>
+      <p:sp>
+        <p:nvSpPr>
+          <p:cNvPr id="42" name="Rounded Rectangle 41"/>
+          <p:cNvSpPr/>
+          <p:nvPr/>
+        </p:nvSpPr>
+        <p:spPr>
+          <a:xfrm>
+            <a:off x="5934456" y="1097280"/>
+            <a:ext cx="320040" cy="2834639"/>
+          </a:xfrm>
+          <a:prstGeom prst="roundRect">
+            <a:avLst/>
+          </a:prstGeom>
+          <a:solidFill>
+            <a:srgbClr val="0066FF"/>
+          </a:solidFill>
+          <a:ln>
+            <a:noFill/>
+          </a:ln>
+          <a:effectLst/>
+        </p:spPr>
+        <p:style>
+          <a:lnRef idx="1">
+            <a:schemeClr val="accent1"/>
+          </a:lnRef>
+          <a:fillRef idx="3">
+            <a:schemeClr val="accent1"/>
+          </a:fillRef>
+          <a:effectRef idx="2">
+            <a:schemeClr val="accent1"/>
+          </a:effectRef>
+          <a:fontRef idx="minor">
+            <a:schemeClr val="lt1"/>
+          </a:fontRef>
+        </p:style>
+        <p:txBody>
+          <a:bodyPr rtlCol="0" anchor="ctr"/>
+          <a:lstStyle/>
+          <a:p>
+            <a:pPr algn="ctr"/>
+          </a:p>
+        </p:txBody>
+      </p:sp>
+      <p:sp>
+        <p:nvSpPr>
+          <p:cNvPr id="43" name="TextBox 42"/>
+          <p:cNvSpPr txBox="1"/>
+          <p:nvPr/>
+        </p:nvSpPr>
+        <p:spPr>
+          <a:xfrm>
+            <a:off x="5577840" y="2313432"/>
+            <a:ext cx="320040" cy="182880"/>
+          </a:xfrm>
+          <a:prstGeom prst="rect">
+            <a:avLst/>
+          </a:prstGeom>
+          <a:noFill/>
+        </p:spPr>
+        <p:txBody>
+          <a:bodyPr wrap="square" tIns="0" bIns="0" lIns="0" rIns="0">
+            <a:spAutoFit/>
+          </a:bodyPr>
+          <a:lstStyle/>
+          <a:p>
+            <a:pPr algn="ctr">
+              <a:defRPr sz="700" b="1">
+                <a:solidFill>
+                  <a:srgbClr val="A0A0A0"/>
+                </a:solidFill>
+                <a:latin typeface="Inter"/>
+              </a:defRPr>
+            </a:pPr>
+            <a:r>
+              <a:t>5</a:t>
+            </a:r>
+          </a:p>
+        </p:txBody>
+      </p:sp>
+      <p:sp>
+        <p:nvSpPr>
+          <p:cNvPr id="44" name="TextBox 43"/>
+          <p:cNvSpPr txBox="1"/>
+          <p:nvPr/>
+        </p:nvSpPr>
+        <p:spPr>
+          <a:xfrm>
+            <a:off x="5934456" y="896112"/>
+            <a:ext cx="320040" cy="182880"/>
+          </a:xfrm>
+          <a:prstGeom prst="rect">
+            <a:avLst/>
+          </a:prstGeom>
+          <a:noFill/>
+        </p:spPr>
+        <p:txBody>
+          <a:bodyPr wrap="square" tIns="0" bIns="0" lIns="0" rIns="0">
+            <a:spAutoFit/>
+          </a:bodyPr>
+          <a:lstStyle/>
+          <a:p>
+            <a:pPr algn="ctr">
+              <a:defRPr sz="700" b="1">
+                <a:solidFill>
+                  <a:srgbClr val="4A8AFF"/>
+                </a:solidFill>
+                <a:latin typeface="Inter"/>
+              </a:defRPr>
+            </a:pPr>
+            <a:r>
+              <a:t>10</a:t>
+            </a:r>
+          </a:p>
+        </p:txBody>
+      </p:sp>
+      <p:sp>
+        <p:nvSpPr>
+          <p:cNvPr id="45" name="TextBox 44"/>
+          <p:cNvSpPr txBox="1"/>
+          <p:nvPr/>
+        </p:nvSpPr>
+        <p:spPr>
+          <a:xfrm>
+            <a:off x="5532120" y="4005072"/>
+            <a:ext cx="768096" cy="274320"/>
+          </a:xfrm>
+          <a:prstGeom prst="rect">
+            <a:avLst/>
+          </a:prstGeom>
+          <a:noFill/>
+        </p:spPr>
+        <p:txBody>
+          <a:bodyPr wrap="square" tIns="0" bIns="0" lIns="0" rIns="0">
+            <a:spAutoFit/>
+          </a:bodyPr>
+          <a:lstStyle/>
+          <a:p>
+            <a:pPr algn="ctr">
+              <a:defRPr sz="700" b="0">
+                <a:solidFill>
+                  <a:srgbClr val="A0A0A0"/>
+                </a:solidFill>
+                <a:latin typeface="Inter"/>
+              </a:defRPr>
+            </a:pPr>
+            <a:r>
+              <a:t>Startup mindset</a:t>
+            </a:r>
+          </a:p>
+        </p:txBody>
+      </p:sp>
+      <p:sp>
+        <p:nvSpPr>
+          <p:cNvPr id="46" name="Rounded Rectangle 45"/>
+          <p:cNvSpPr/>
+          <p:nvPr/>
+        </p:nvSpPr>
+        <p:spPr>
+          <a:xfrm>
+            <a:off x="731520" y="4434840"/>
+            <a:ext cx="164592" cy="118872"/>
+          </a:xfrm>
+          <a:prstGeom prst="roundRect">
+            <a:avLst/>
+          </a:prstGeom>
+          <a:solidFill>
+            <a:srgbClr val="5A5A5E"/>
+          </a:solidFill>
+          <a:ln>
+            <a:noFill/>
+          </a:ln>
+          <a:effectLst/>
+        </p:spPr>
+        <p:style>
+          <a:lnRef idx="1">
+            <a:schemeClr val="accent1"/>
+          </a:lnRef>
+          <a:fillRef idx="3">
+            <a:schemeClr val="accent1"/>
+          </a:fillRef>
+          <a:effectRef idx="2">
+            <a:schemeClr val="accent1"/>
+          </a:effectRef>
+          <a:fontRef idx="minor">
+            <a:schemeClr val="lt1"/>
+          </a:fontRef>
+        </p:style>
+        <p:txBody>
+          <a:bodyPr rtlCol="0" anchor="ctr"/>
+          <a:lstStyle/>
+          <a:p>
+            <a:pPr algn="ctr"/>
+          </a:p>
+        </p:txBody>
+      </p:sp>
+      <p:sp>
+        <p:nvSpPr>
+          <p:cNvPr id="47" name="TextBox 46"/>
+          <p:cNvSpPr txBox="1"/>
+          <p:nvPr/>
+        </p:nvSpPr>
+        <p:spPr>
+          <a:xfrm>
+            <a:off x="960120" y="4416552"/>
+            <a:ext cx="1371600" cy="182880"/>
+          </a:xfrm>
+          <a:prstGeom prst="rect">
+            <a:avLst/>
+          </a:prstGeom>
+          <a:noFill/>
+        </p:spPr>
+        <p:txBody>
+          <a:bodyPr wrap="square" tIns="0" bIns="0" lIns="0" rIns="0">
+            <a:spAutoFit/>
+          </a:bodyPr>
+          <a:lstStyle/>
+          <a:p>
+            <a:pPr algn="l">
+              <a:defRPr sz="700" b="0">
+                <a:solidFill>
+                  <a:srgbClr val="A0A0A0"/>
+                </a:solidFill>
+                <a:latin typeface="Inter"/>
+              </a:defRPr>
+            </a:pPr>
+            <a:r>
+              <a:t>JD Requirement (/10)</a:t>
+            </a:r>
+          </a:p>
+        </p:txBody>
+      </p:sp>
+      <p:sp>
+        <p:nvSpPr>
+          <p:cNvPr id="48" name="Rounded Rectangle 47"/>
+          <p:cNvSpPr/>
+          <p:nvPr/>
+        </p:nvSpPr>
+        <p:spPr>
+          <a:xfrm>
+            <a:off x="2743200" y="4434840"/>
+            <a:ext cx="164592" cy="118872"/>
+          </a:xfrm>
+          <a:prstGeom prst="roundRect">
+            <a:avLst/>
+          </a:prstGeom>
+          <a:solidFill>
+            <a:srgbClr val="0066FF"/>
+          </a:solidFill>
+          <a:ln>
+            <a:noFill/>
+          </a:ln>
+          <a:effectLst/>
+        </p:spPr>
+        <p:style>
+          <a:lnRef idx="1">
+            <a:schemeClr val="accent1"/>
+          </a:lnRef>
+          <a:fillRef idx="3">
+            <a:schemeClr val="accent1"/>
+          </a:fillRef>
+          <a:effectRef idx="2">
+            <a:schemeClr val="accent1"/>
+          </a:effectRef>
+          <a:fontRef idx="minor">
+            <a:schemeClr val="lt1"/>
+          </a:fontRef>
+        </p:style>
+        <p:txBody>
+          <a:bodyPr rtlCol="0" anchor="ctr"/>
+          <a:lstStyle/>
+          <a:p>
+            <a:pPr algn="ctr"/>
+          </a:p>
+        </p:txBody>
+      </p:sp>
+      <p:sp>
+        <p:nvSpPr>
+          <p:cNvPr id="49" name="TextBox 48"/>
+          <p:cNvSpPr txBox="1"/>
+          <p:nvPr/>
+        </p:nvSpPr>
+        <p:spPr>
+          <a:xfrm>
+            <a:off x="2971800" y="4416552"/>
+            <a:ext cx="1371600" cy="182880"/>
+          </a:xfrm>
+          <a:prstGeom prst="rect">
+            <a:avLst/>
+          </a:prstGeom>
+          <a:noFill/>
+        </p:spPr>
+        <p:txBody>
+          <a:bodyPr wrap="square" tIns="0" bIns="0" lIns="0" rIns="0">
+            <a:spAutoFit/>
+          </a:bodyPr>
+          <a:lstStyle/>
+          <a:p>
+            <a:pPr algn="l">
+              <a:defRPr sz="700" b="0">
+                <a:solidFill>
+                  <a:srgbClr val="A0A0A0"/>
+                </a:solidFill>
+                <a:latin typeface="Inter"/>
+              </a:defRPr>
+            </a:pPr>
+            <a:r>
+              <a:t>Shruti Evidence (/10)</a:t>
+            </a:r>
+          </a:p>
+        </p:txBody>
+      </p:sp>
+      <p:sp>
+        <p:nvSpPr>
+          <p:cNvPr id="50" name="TextBox 49"/>
+          <p:cNvSpPr txBox="1"/>
+          <p:nvPr/>
+        </p:nvSpPr>
+        <p:spPr>
+          <a:xfrm>
+            <a:off x="6583680" y="1280160"/>
+            <a:ext cx="2286000" cy="274320"/>
           </a:xfrm>
           <a:prstGeom prst="rect">
             <a:avLst/>
@@ -4483,14 +6018,14 @@
       </p:sp>
       <p:sp>
         <p:nvSpPr>
-          <p:cNvPr id="6" name="TextBox 5"/>
-          <p:cNvSpPr txBox="1"/>
-          <p:nvPr/>
-        </p:nvSpPr>
-        <p:spPr>
-          <a:xfrm>
-            <a:off x="5943600" y="1463040"/>
-            <a:ext cx="2926080" cy="2743200"/>
+          <p:cNvPr id="51" name="TextBox 50"/>
+          <p:cNvSpPr txBox="1"/>
+          <p:nvPr/>
+        </p:nvSpPr>
+        <p:spPr>
+          <a:xfrm>
+            <a:off x="6583680" y="1645920"/>
+            <a:ext cx="2286000" cy="1828800"/>
           </a:xfrm>
           <a:prstGeom prst="rect">
             <a:avLst/>
@@ -4515,7 +6050,7 @@
               </a:defRPr>
             </a:pPr>
             <a:r>
-              <a:t>•  Strong match on every JD requirement</a:t>
+              <a:t>•  Strong match on every core requirement</a:t>
             </a:r>
           </a:p>
           <a:p>
@@ -4531,7 +6066,7 @@
               </a:defRPr>
             </a:pPr>
             <a:r>
-              <a:t>•  Exceeds on startup/entrepreneurial (nice-to-have is core strength)</a:t>
+              <a:t>•  Exceeds on startup/entrepreneurial</a:t>
             </a:r>
           </a:p>
           <a:p>
@@ -4547,7 +6082,7 @@
               </a:defRPr>
             </a:pPr>
             <a:r>
-              <a:t>•  Weakest area (user testing) still backed by Elixr A/B testing + iwoca iterations</a:t>
+              <a:t>•  Weakest: user testing (still 8/10)</a:t>
             </a:r>
           </a:p>
         </p:txBody>

</xml_diff>

<commit_message>
Add dynamic bar chart sizing logic to prevent overflow
Bar width and gap now computed from category count and available space.
If too many categories, skill instructs to split across slides.
Key takeaway capped at 3 short bullets.
</commit_message>
<xml_diff>
--- a/samples/Shruti_Revolut_WhyHireMe_Portfolio.pptx
+++ b/samples/Shruti_Revolut_WhyHireMe_Portfolio.pptx
@@ -4173,7 +4173,7 @@
         <p:spPr>
           <a:xfrm>
             <a:off x="731520" y="3931920"/>
-            <a:ext cx="5522975" cy="2743"/>
+            <a:ext cx="5486400" cy="2743"/>
           </a:xfrm>
           <a:prstGeom prst="rect">
             <a:avLst/>
@@ -4253,7 +4253,7 @@
         <p:spPr>
           <a:xfrm>
             <a:off x="731520" y="3364991"/>
-            <a:ext cx="5522975" cy="2743"/>
+            <a:ext cx="5486400" cy="2743"/>
           </a:xfrm>
           <a:prstGeom prst="rect">
             <a:avLst/>
@@ -4333,7 +4333,7 @@
         <p:spPr>
           <a:xfrm>
             <a:off x="731520" y="2798063"/>
-            <a:ext cx="5522975" cy="2743"/>
+            <a:ext cx="5486400" cy="2743"/>
           </a:xfrm>
           <a:prstGeom prst="rect">
             <a:avLst/>
@@ -4413,7 +4413,7 @@
         <p:spPr>
           <a:xfrm>
             <a:off x="731520" y="2231136"/>
-            <a:ext cx="5522975" cy="2743"/>
+            <a:ext cx="5486400" cy="2743"/>
           </a:xfrm>
           <a:prstGeom prst="rect">
             <a:avLst/>
@@ -4493,7 +4493,7 @@
         <p:spPr>
           <a:xfrm>
             <a:off x="731520" y="1664207"/>
-            <a:ext cx="5522975" cy="2743"/>
+            <a:ext cx="5486400" cy="2743"/>
           </a:xfrm>
           <a:prstGeom prst="rect">
             <a:avLst/>
@@ -4573,7 +4573,7 @@
         <p:spPr>
           <a:xfrm>
             <a:off x="731520" y="1097280"/>
-            <a:ext cx="5522975" cy="2743"/>
+            <a:ext cx="5486400" cy="2743"/>
           </a:xfrm>
           <a:prstGeom prst="rect">
             <a:avLst/>
@@ -4653,7 +4653,7 @@
         <p:spPr>
           <a:xfrm>
             <a:off x="731520" y="1097280"/>
-            <a:ext cx="320040" cy="2834639"/>
+            <a:ext cx="351129" cy="2834639"/>
           </a:xfrm>
           <a:prstGeom prst="roundRect">
             <a:avLst/>
@@ -4696,8 +4696,8 @@
         </p:nvSpPr>
         <p:spPr>
           <a:xfrm>
-            <a:off x="1088136" y="1380744"/>
-            <a:ext cx="320040" cy="2551175"/>
+            <a:off x="1119225" y="1380744"/>
+            <a:ext cx="351129" cy="2551175"/>
           </a:xfrm>
           <a:prstGeom prst="roundRect">
             <a:avLst/>
@@ -4741,7 +4741,7 @@
         <p:spPr>
           <a:xfrm>
             <a:off x="731520" y="896112"/>
-            <a:ext cx="320040" cy="182880"/>
+            <a:ext cx="351129" cy="182880"/>
           </a:xfrm>
           <a:prstGeom prst="rect">
             <a:avLst/>
@@ -4776,8 +4776,8 @@
         </p:nvSpPr>
         <p:spPr>
           <a:xfrm>
-            <a:off x="1088136" y="1179576"/>
-            <a:ext cx="320040" cy="182880"/>
+            <a:off x="1119225" y="1179576"/>
+            <a:ext cx="351129" cy="182880"/>
           </a:xfrm>
           <a:prstGeom prst="rect">
             <a:avLst/>
@@ -4813,7 +4813,7 @@
         <p:spPr>
           <a:xfrm>
             <a:off x="685800" y="4005072"/>
-            <a:ext cx="768096" cy="274320"/>
+            <a:ext cx="830275" cy="274320"/>
           </a:xfrm>
           <a:prstGeom prst="rect">
             <a:avLst/>
@@ -4848,8 +4848,8 @@
         </p:nvSpPr>
         <p:spPr>
           <a:xfrm>
-            <a:off x="1700784" y="1097280"/>
-            <a:ext cx="320040" cy="2834639"/>
+            <a:off x="1681032" y="1097280"/>
+            <a:ext cx="351129" cy="2834639"/>
           </a:xfrm>
           <a:prstGeom prst="roundRect">
             <a:avLst/>
@@ -4892,8 +4892,8 @@
         </p:nvSpPr>
         <p:spPr>
           <a:xfrm>
-            <a:off x="2057400" y="1380744"/>
-            <a:ext cx="320040" cy="2551175"/>
+            <a:off x="2068738" y="1380744"/>
+            <a:ext cx="351129" cy="2551175"/>
           </a:xfrm>
           <a:prstGeom prst="roundRect">
             <a:avLst/>
@@ -4936,8 +4936,8 @@
         </p:nvSpPr>
         <p:spPr>
           <a:xfrm>
-            <a:off x="1700784" y="896112"/>
-            <a:ext cx="320040" cy="182880"/>
+            <a:off x="1681032" y="896112"/>
+            <a:ext cx="351129" cy="182880"/>
           </a:xfrm>
           <a:prstGeom prst="rect">
             <a:avLst/>
@@ -4972,8 +4972,8 @@
         </p:nvSpPr>
         <p:spPr>
           <a:xfrm>
-            <a:off x="2057400" y="1179576"/>
-            <a:ext cx="320040" cy="182880"/>
+            <a:off x="2068738" y="1179576"/>
+            <a:ext cx="351129" cy="182880"/>
           </a:xfrm>
           <a:prstGeom prst="rect">
             <a:avLst/>
@@ -5008,8 +5008,8 @@
         </p:nvSpPr>
         <p:spPr>
           <a:xfrm>
-            <a:off x="1655064" y="4005072"/>
-            <a:ext cx="768096" cy="274320"/>
+            <a:off x="1635312" y="4005072"/>
+            <a:ext cx="830275" cy="274320"/>
           </a:xfrm>
           <a:prstGeom prst="rect">
             <a:avLst/>
@@ -5044,8 +5044,8 @@
         </p:nvSpPr>
         <p:spPr>
           <a:xfrm>
-            <a:off x="2670048" y="1097280"/>
-            <a:ext cx="320040" cy="2834639"/>
+            <a:off x="2630545" y="1097280"/>
+            <a:ext cx="351129" cy="2834639"/>
           </a:xfrm>
           <a:prstGeom prst="roundRect">
             <a:avLst/>
@@ -5088,8 +5088,8 @@
         </p:nvSpPr>
         <p:spPr>
           <a:xfrm>
-            <a:off x="3026664" y="1097280"/>
-            <a:ext cx="320040" cy="2834639"/>
+            <a:off x="3018251" y="1097280"/>
+            <a:ext cx="351129" cy="2834639"/>
           </a:xfrm>
           <a:prstGeom prst="roundRect">
             <a:avLst/>
@@ -5132,8 +5132,8 @@
         </p:nvSpPr>
         <p:spPr>
           <a:xfrm>
-            <a:off x="2670048" y="896112"/>
-            <a:ext cx="320040" cy="182880"/>
+            <a:off x="2630545" y="896112"/>
+            <a:ext cx="351129" cy="182880"/>
           </a:xfrm>
           <a:prstGeom prst="rect">
             <a:avLst/>
@@ -5168,8 +5168,8 @@
         </p:nvSpPr>
         <p:spPr>
           <a:xfrm>
-            <a:off x="3026664" y="896112"/>
-            <a:ext cx="320040" cy="182880"/>
+            <a:off x="3018251" y="896112"/>
+            <a:ext cx="351129" cy="182880"/>
           </a:xfrm>
           <a:prstGeom prst="rect">
             <a:avLst/>
@@ -5204,8 +5204,8 @@
         </p:nvSpPr>
         <p:spPr>
           <a:xfrm>
-            <a:off x="2624328" y="4005072"/>
-            <a:ext cx="768096" cy="274320"/>
+            <a:off x="2584825" y="4005072"/>
+            <a:ext cx="830275" cy="274320"/>
           </a:xfrm>
           <a:prstGeom prst="rect">
             <a:avLst/>
@@ -5240,8 +5240,8 @@
         </p:nvSpPr>
         <p:spPr>
           <a:xfrm>
-            <a:off x="3639312" y="1097280"/>
-            <a:ext cx="320040" cy="2834639"/>
+            <a:off x="3580058" y="1097280"/>
+            <a:ext cx="351129" cy="2834639"/>
           </a:xfrm>
           <a:prstGeom prst="roundRect">
             <a:avLst/>
@@ -5284,8 +5284,8 @@
         </p:nvSpPr>
         <p:spPr>
           <a:xfrm>
-            <a:off x="3995928" y="1664207"/>
-            <a:ext cx="320040" cy="2267712"/>
+            <a:off x="3967764" y="1664207"/>
+            <a:ext cx="351129" cy="2267712"/>
           </a:xfrm>
           <a:prstGeom prst="roundRect">
             <a:avLst/>
@@ -5328,8 +5328,8 @@
         </p:nvSpPr>
         <p:spPr>
           <a:xfrm>
-            <a:off x="3639312" y="896112"/>
-            <a:ext cx="320040" cy="182880"/>
+            <a:off x="3580058" y="896112"/>
+            <a:ext cx="351129" cy="182880"/>
           </a:xfrm>
           <a:prstGeom prst="rect">
             <a:avLst/>
@@ -5364,8 +5364,8 @@
         </p:nvSpPr>
         <p:spPr>
           <a:xfrm>
-            <a:off x="3995928" y="1463039"/>
-            <a:ext cx="320040" cy="182880"/>
+            <a:off x="3967764" y="1463039"/>
+            <a:ext cx="351129" cy="182880"/>
           </a:xfrm>
           <a:prstGeom prst="rect">
             <a:avLst/>
@@ -5400,8 +5400,8 @@
         </p:nvSpPr>
         <p:spPr>
           <a:xfrm>
-            <a:off x="3593592" y="4005072"/>
-            <a:ext cx="768096" cy="274320"/>
+            <a:off x="3534338" y="4005072"/>
+            <a:ext cx="830275" cy="274320"/>
           </a:xfrm>
           <a:prstGeom prst="rect">
             <a:avLst/>
@@ -5436,8 +5436,8 @@
         </p:nvSpPr>
         <p:spPr>
           <a:xfrm>
-            <a:off x="4608576" y="1097280"/>
-            <a:ext cx="320040" cy="2834639"/>
+            <a:off x="4529571" y="1097280"/>
+            <a:ext cx="351129" cy="2834639"/>
           </a:xfrm>
           <a:prstGeom prst="roundRect">
             <a:avLst/>
@@ -5480,8 +5480,8 @@
         </p:nvSpPr>
         <p:spPr>
           <a:xfrm>
-            <a:off x="4965192" y="1380744"/>
-            <a:ext cx="320040" cy="2551175"/>
+            <a:off x="4917277" y="1380744"/>
+            <a:ext cx="351129" cy="2551175"/>
           </a:xfrm>
           <a:prstGeom prst="roundRect">
             <a:avLst/>
@@ -5524,8 +5524,8 @@
         </p:nvSpPr>
         <p:spPr>
           <a:xfrm>
-            <a:off x="4608576" y="896112"/>
-            <a:ext cx="320040" cy="182880"/>
+            <a:off x="4529571" y="896112"/>
+            <a:ext cx="351129" cy="182880"/>
           </a:xfrm>
           <a:prstGeom prst="rect">
             <a:avLst/>
@@ -5560,8 +5560,8 @@
         </p:nvSpPr>
         <p:spPr>
           <a:xfrm>
-            <a:off x="4965192" y="1179576"/>
-            <a:ext cx="320040" cy="182880"/>
+            <a:off x="4917277" y="1179576"/>
+            <a:ext cx="351129" cy="182880"/>
           </a:xfrm>
           <a:prstGeom prst="rect">
             <a:avLst/>
@@ -5596,8 +5596,8 @@
         </p:nvSpPr>
         <p:spPr>
           <a:xfrm>
-            <a:off x="4562856" y="4005072"/>
-            <a:ext cx="768096" cy="274320"/>
+            <a:off x="4483851" y="4005072"/>
+            <a:ext cx="830275" cy="274320"/>
           </a:xfrm>
           <a:prstGeom prst="rect">
             <a:avLst/>
@@ -5632,8 +5632,8 @@
         </p:nvSpPr>
         <p:spPr>
           <a:xfrm>
-            <a:off x="5577840" y="2514600"/>
-            <a:ext cx="320040" cy="1417319"/>
+            <a:off x="5479084" y="2514600"/>
+            <a:ext cx="351129" cy="1417319"/>
           </a:xfrm>
           <a:prstGeom prst="roundRect">
             <a:avLst/>
@@ -5676,8 +5676,8 @@
         </p:nvSpPr>
         <p:spPr>
           <a:xfrm>
-            <a:off x="5934456" y="1097280"/>
-            <a:ext cx="320040" cy="2834639"/>
+            <a:off x="5866790" y="1097280"/>
+            <a:ext cx="351129" cy="2834639"/>
           </a:xfrm>
           <a:prstGeom prst="roundRect">
             <a:avLst/>
@@ -5720,8 +5720,8 @@
         </p:nvSpPr>
         <p:spPr>
           <a:xfrm>
-            <a:off x="5577840" y="2313432"/>
-            <a:ext cx="320040" cy="182880"/>
+            <a:off x="5479084" y="2313432"/>
+            <a:ext cx="351129" cy="182880"/>
           </a:xfrm>
           <a:prstGeom prst="rect">
             <a:avLst/>
@@ -5756,8 +5756,8 @@
         </p:nvSpPr>
         <p:spPr>
           <a:xfrm>
-            <a:off x="5934456" y="896112"/>
-            <a:ext cx="320040" cy="182880"/>
+            <a:off x="5866790" y="896112"/>
+            <a:ext cx="351129" cy="182880"/>
           </a:xfrm>
           <a:prstGeom prst="rect">
             <a:avLst/>
@@ -5792,8 +5792,8 @@
         </p:nvSpPr>
         <p:spPr>
           <a:xfrm>
-            <a:off x="5532120" y="4005072"/>
-            <a:ext cx="768096" cy="274320"/>
+            <a:off x="5433364" y="4005072"/>
+            <a:ext cx="830275" cy="274320"/>
           </a:xfrm>
           <a:prstGeom prst="rect">
             <a:avLst/>

</xml_diff>